<commit_message>
docs(presentation): tighten deck copy
Remove slogan titles, binary contrasts, passive constructions and filler; keep every number, status and evidence claim unchanged. Re-export PPTX/PDF and save HTML revision 4.
</commit_message>
<xml_diff>
--- a/docs/presentation/20261023/PrivacyTrace-汇报-20261023.pptx
+++ b/docs/presentation/20261023/PrivacyTrace-汇报-20261023.pptx
@@ -519,7 +519,7 @@
           <a:p>
             <a:r>
               <a:rPr lang="en-US" dirty="0"/>
-              <a:t>开场只讲三件事：作品一句话定位、这稿的证据来源、以及一个诚实的版本说明——前端还在迁移，所以界面截图不是最终视觉。</a:t>
+              <a:t>开场讲三件事：一句话定位、证据来源、版本说明。前端还在迁移，截图不是最终视觉。</a:t>
             </a:r>
             <a:endParaRPr lang="en-US" dirty="0"/>
           </a:p>
@@ -607,7 +607,7 @@
           <a:p>
             <a:r>
               <a:rPr lang="en-US" dirty="0"/>
-              <a:t>这一项的价值是「让别人能复核」：扫描在受限容器里跑，交付包打开前先验哈希。参数写死在代码与文档里，可以检查。</a:t>
+              <a:t>这一项让评审能复核。扫描在受限容器里跑，交付包打开前先验哈希；参数写在代码和文档里。</a:t>
             </a:r>
             <a:endParaRPr lang="en-US" dirty="0"/>
           </a:p>
@@ -695,7 +695,7 @@
           <a:p>
             <a:r>
               <a:rPr lang="en-US" dirty="0"/>
-              <a:t>工作流本身不复杂，复杂的是每一步的状态都不能被悄悄跳过。右边这张表是全稿的引用口径：任何数字先问它属于哪一层证据。</a:t>
+              <a:t>工作流不复杂。难的是每一步状态都不能悄悄跳过。右边这张表是全稿的引用口径：任何数字先问它属于哪一层证据。</a:t>
             </a:r>
             <a:endParaRPr lang="en-US" dirty="0"/>
           </a:p>
@@ -783,7 +783,7 @@
           <a:p>
             <a:r>
               <a:rPr lang="en-US" dirty="0"/>
-              <a:t>工程管理不是「开了多少会」，而是三件事：谁负责、怎么验、证据绑在哪个版本上。最后一行说明材料本身也是按这个纪律做的。</a:t>
+              <a:t>工程管理看三件事：谁负责、怎么验、证据绑在哪个版本上。最后一行说明材料本身也按这个纪律做。</a:t>
             </a:r>
             <a:endParaRPr lang="en-US" dirty="0"/>
           </a:p>
@@ -871,7 +871,7 @@
           <a:p>
             <a:r>
               <a:rPr lang="en-US" dirty="0"/>
-              <a:t>这是全稿最容易被过度解读的数字。说完 12/12，立刻说它不能证明什么，并保留原六场景的历史数字。</a:t>
+              <a:t>12/12 最容易读过头。说完这个数，马上说它不能证明什么，再补原六场景的历史数字。</a:t>
             </a:r>
             <a:endParaRPr lang="en-US" dirty="0"/>
           </a:p>
@@ -959,7 +959,7 @@
           <a:p>
             <a:r>
               <a:rPr lang="en-US" dirty="0"/>
-              <a:t>成果页必须带反证。理解测试暴露了报告层级问题，H12 暴露了配置组合缺陷——把这两件事写出来，比多报一个漂亮数字更可信。</a:t>
+              <a:t>成果页带反证。理解测试暴露报告层级问题，H12 暴露配置组合缺陷。这两件事写出来，比多一个漂亮数字可信。</a:t>
             </a:r>
             <a:endParaRPr lang="en-US" dirty="0"/>
           </a:p>
@@ -1047,7 +1047,7 @@
           <a:p>
             <a:r>
               <a:rPr lang="en-US" dirty="0"/>
-              <a:t>界面页只讲「可复核」怎么落地：来源状态、失败来源保留、回放不重扫。最后一句主动说明前端仍在迁移。</a:t>
+              <a:t>界面页讲可复核怎么落地：来源状态、失败来源保留、回放不重扫。最后一句说明前端还在迁移。</a:t>
             </a:r>
             <a:endParaRPr lang="en-US" dirty="0"/>
           </a:p>
@@ -1135,7 +1135,7 @@
           <a:p>
             <a:r>
               <a:rPr lang="en-US" dirty="0"/>
-              <a:t>两张图分别证明「证据能下钻」和「移动端能用同一份报告」。Figure 6 里那句「本项只是清单权限能力，不代表实际访问」是产品语气的核心。</a:t>
+              <a:t>两张图分别证明证据能下钻、手机能看同一份报告。Figure 6 里「本项只是清单权限能力，不代表实际访问」这句最能说明产品语气。</a:t>
             </a:r>
             <a:endParaRPr lang="en-US" dirty="0"/>
           </a:p>
@@ -1223,7 +1223,7 @@
           <a:p>
             <a:r>
               <a:rPr lang="en-US" dirty="0"/>
-              <a:t>原创贡献按「可核验的工作」写，不按「谁写得最多」写。AI 参与如实说，但不把 AI 说成产品能力，也不虚构一个自主率。</a:t>
+              <a:t>原创贡献按可核验的工作写，不按谁写得多。AI 参与如实说；不把 AI 说成产品能力，也不虚构自主率。</a:t>
             </a:r>
             <a:endParaRPr lang="en-US" dirty="0"/>
           </a:p>
@@ -1311,7 +1311,7 @@
           <a:p>
             <a:r>
               <a:rPr lang="en-US" dirty="0"/>
-              <a:t>收尾不喊口号：三句话分别对应定位、创新、边界，最后把证据索引交出去。留一句「以随包证据为准」，是给评审的复核入口。</a:t>
+              <a:t>收尾三句话对应定位、创新、边界，最后交出证据索引。「以随包证据为准」是给评审的复核入口。</a:t>
             </a:r>
             <a:endParaRPr lang="en-US" dirty="0"/>
           </a:p>
@@ -1399,7 +1399,7 @@
           <a:p>
             <a:r>
               <a:rPr lang="en-US" dirty="0"/>
-              <a:t>先给评审一张地图：定位、创新、方法、成果、贡献。并先把三种证据的口径说清楚，后面所有数字都按这个口径引用。</a:t>
+              <a:t>先给评审一张地图。三种证据的口径先说清楚，后面所有数字都按它引用。</a:t>
             </a:r>
             <a:endParaRPr lang="en-US" dirty="0"/>
           </a:p>
@@ -1487,7 +1487,7 @@
           <a:p>
             <a:r>
               <a:rPr lang="en-US" dirty="0"/>
-              <a:t>第一节只回答一个问题：这个作品是什么、不是什么。它决定了后面所有创新与边界的写法。</a:t>
+              <a:t>第一节回答一个问题：这个作品做什么。后面的创新和边界都从这里长出来。</a:t>
             </a:r>
             <a:endParaRPr lang="en-US" dirty="0"/>
           </a:p>
@@ -1575,7 +1575,7 @@
           <a:p>
             <a:r>
               <a:rPr lang="en-US" dirty="0"/>
-              <a:t>强调三条「不做」不是能力不足的托词，而是产品定位：把判定权留给用户。三个卡片分别对应受众、范围、边界。</a:t>
+              <a:t>三条「不做」属于产品定位，把判定权留给用户。三张卡片对应受众、范围和边界。</a:t>
             </a:r>
             <a:endParaRPr lang="en-US" dirty="0"/>
           </a:p>
@@ -1663,7 +1663,7 @@
           <a:p>
             <a:r>
               <a:rPr lang="en-US" dirty="0"/>
-              <a:t>这张图说明产品不是「给一个结论」，而是「给一条可走的路」。下钻两次分别到代码位置和政策全文，偏移量可以自己算。</a:t>
+              <a:t>这张图说明产品给的是可走的路。两次下钻分别到代码位置和政策全文，偏移量可以自己算。</a:t>
             </a:r>
             <a:endParaRPr lang="en-US" dirty="0"/>
           </a:p>
@@ -1751,7 +1751,7 @@
           <a:p>
             <a:r>
               <a:rPr lang="en-US" dirty="0"/>
-              <a:t>第二节是评审最关心的部分：创新必须落到具体设计、具体文件、具体数字，而不是形容词。</a:t>
+              <a:t>第二节让创新落到设计、文件和数字上，不靠形容词。</a:t>
             </a:r>
             <a:endParaRPr lang="en-US" dirty="0"/>
           </a:p>
@@ -1839,7 +1839,7 @@
           <a:p>
             <a:r>
               <a:rPr lang="en-US" dirty="0"/>
-              <a:t>这一页用真实样本说明「双向」不是口号：代码侧给到字节码偏移和目标描述符，政策侧给到码点区间；两侧对不上，就只能是证据不足。</a:t>
+              <a:t>真实样本里，代码侧给字节码偏移和目标描述符，政策侧给码点区间。两侧对不上，结论只能是证据不足。</a:t>
             </a:r>
             <a:endParaRPr lang="en-US" dirty="0"/>
           </a:p>
@@ -1927,7 +1927,7 @@
           <a:p>
             <a:r>
               <a:rPr lang="en-US" dirty="0"/>
-              <a:t>创新点不在「多识别了几个 API」，而在「识别不出时怎么写」。我们让证据不足成为一等状态，而不是用推断补齐。</a:t>
+              <a:t>创新点在识别不出时怎么写。证据不足是一等状态，不用推断补齐。</a:t>
             </a:r>
             <a:endParaRPr lang="en-US" dirty="0"/>
           </a:p>
@@ -2015,7 +2015,7 @@
           <a:p>
             <a:r>
               <a:rPr lang="en-US" dirty="0"/>
-              <a:t>评测最容易造假的地方是「先看结果再定真值」。这里反过来：真值先冻结并哈希，算法容器不挂载真值目录，修订必须另建版本。</a:t>
+              <a:t>评测最容易造假的环节是先看结果再定真值。我们把顺序倒过来：真值先冻结并哈希，算法容器不挂载真值目录，修订另建版本。</a:t>
             </a:r>
             <a:endParaRPr lang="en-US" dirty="0"/>
           </a:p>

</xml_diff>